<commit_message>
docs: add proposed next-steps workflow slide to KB restructure deck
Adds slide 9 with the prioritized 9-step workflow: audit analysis,
team alignment, artifact review, Leema feedback integration, gap-fill
validation, PM 1:1s, Support diff, Phase 3a content creation, and
pre-merge review pass.

Co-Authored-By: Claude Sonnet 4.6 <noreply@anthropic.com>
</commit_message>
<xml_diff>
--- a/KB-Restructure-Executive-Summary.pptx
+++ b/KB-Restructure-Executive-Summary.pptx
@@ -13,6 +13,7 @@
     <p:sldId id="261" r:id="rId7"/>
     <p:sldId id="262" r:id="rId8"/>
     <p:sldId id="263" r:id="rId9"/>
+    <p:sldId id="264" r:id="rId14"/>
   </p:sldIdLst>
   <p:sldSz cx="12188825" cy="6858000"/>
   <p:notesSz cx="6858000" cy="9144000"/>
@@ -22309,6 +22310,2609 @@
                 <a:latin typeface="Calibri"/>
               </a:rPr>
               <a:t>Every article has Next Steps</a:t>
+            </a:r>
+          </a:p>
+        </p:txBody>
+      </p:sp>
+    </p:spTree>
+  </p:cSld>
+  <p:clrMapOvr>
+    <a:masterClrMapping/>
+  </p:clrMapOvr>
+</p:sld>
+</file>
+
+<file path=ppt/slides/slide9.xml><?xml version="1.0" encoding="utf-8"?>
+<p:sld xmlns:a="http://schemas.openxmlformats.org/drawingml/2006/main" xmlns:p="http://schemas.openxmlformats.org/presentationml/2006/main" xmlns:r="http://schemas.openxmlformats.org/officeDocument/2006/relationships">
+  <p:cSld>
+    <p:spTree>
+      <p:nvGrpSpPr>
+        <p:cNvPr id="1" name=""/>
+        <p:cNvGrpSpPr/>
+        <p:nvPr/>
+      </p:nvGrpSpPr>
+      <p:grpSpPr/>
+      <p:sp>
+        <p:nvSpPr>
+          <p:cNvPr id="2" name="Rectangle 1"/>
+          <p:cNvSpPr/>
+          <p:nvPr/>
+        </p:nvSpPr>
+        <p:spPr>
+          <a:xfrm>
+            <a:off x="0" y="0"/>
+            <a:ext cx="12188952" cy="6858000"/>
+          </a:xfrm>
+          <a:prstGeom prst="rect">
+            <a:avLst/>
+          </a:prstGeom>
+          <a:solidFill>
+            <a:srgbClr val="002D6E"/>
+          </a:solidFill>
+          <a:ln>
+            <a:noFill/>
+          </a:ln>
+        </p:spPr>
+        <p:style>
+          <a:lnRef idx="1">
+            <a:schemeClr val="accent1"/>
+          </a:lnRef>
+          <a:fillRef idx="3">
+            <a:schemeClr val="accent1"/>
+          </a:fillRef>
+          <a:effectRef idx="2">
+            <a:schemeClr val="accent1"/>
+          </a:effectRef>
+          <a:fontRef idx="minor">
+            <a:schemeClr val="lt1"/>
+          </a:fontRef>
+        </p:style>
+        <p:txBody>
+          <a:bodyPr rtlCol="0" anchor="ctr"/>
+          <a:lstStyle/>
+          <a:p>
+            <a:pPr algn="ctr"/>
+          </a:p>
+        </p:txBody>
+      </p:sp>
+      <p:sp>
+        <p:nvSpPr>
+          <p:cNvPr id="3" name="Rectangle 2"/>
+          <p:cNvSpPr/>
+          <p:nvPr/>
+        </p:nvSpPr>
+        <p:spPr>
+          <a:xfrm>
+            <a:off x="0" y="0"/>
+            <a:ext cx="12188952" cy="73152"/>
+          </a:xfrm>
+          <a:prstGeom prst="rect">
+            <a:avLst/>
+          </a:prstGeom>
+          <a:solidFill>
+            <a:srgbClr val="00C6CF"/>
+          </a:solidFill>
+          <a:ln>
+            <a:noFill/>
+          </a:ln>
+        </p:spPr>
+        <p:style>
+          <a:lnRef idx="1">
+            <a:schemeClr val="accent1"/>
+          </a:lnRef>
+          <a:fillRef idx="3">
+            <a:schemeClr val="accent1"/>
+          </a:fillRef>
+          <a:effectRef idx="2">
+            <a:schemeClr val="accent1"/>
+          </a:effectRef>
+          <a:fontRef idx="minor">
+            <a:schemeClr val="lt1"/>
+          </a:fontRef>
+        </p:style>
+        <p:txBody>
+          <a:bodyPr rtlCol="0" anchor="ctr"/>
+          <a:lstStyle/>
+          <a:p>
+            <a:pPr algn="ctr"/>
+          </a:p>
+        </p:txBody>
+      </p:sp>
+      <p:sp>
+        <p:nvSpPr>
+          <p:cNvPr id="4" name="TextBox 3"/>
+          <p:cNvSpPr txBox="1"/>
+          <p:nvPr/>
+        </p:nvSpPr>
+        <p:spPr>
+          <a:xfrm>
+            <a:off x="457200" y="137160"/>
+            <a:ext cx="10972800" cy="411480"/>
+          </a:xfrm>
+          <a:prstGeom prst="rect">
+            <a:avLst/>
+          </a:prstGeom>
+          <a:noFill/>
+        </p:spPr>
+        <p:txBody>
+          <a:bodyPr wrap="square">
+            <a:spAutoFit/>
+          </a:bodyPr>
+          <a:lstStyle/>
+          <a:p>
+            <a:pPr algn="l"/>
+            <a:r>
+              <a:rPr sz="2200" b="1" i="0">
+                <a:solidFill>
+                  <a:srgbClr val="FFFFFF"/>
+                </a:solidFill>
+                <a:latin typeface="Calibri"/>
+              </a:rPr>
+              <a:t>Proposed Next Steps  —  Prioritized Workflow</a:t>
+            </a:r>
+          </a:p>
+        </p:txBody>
+      </p:sp>
+      <p:sp>
+        <p:nvSpPr>
+          <p:cNvPr id="5" name="Rectangle 4"/>
+          <p:cNvSpPr/>
+          <p:nvPr/>
+        </p:nvSpPr>
+        <p:spPr>
+          <a:xfrm>
+            <a:off x="457200" y="576072"/>
+            <a:ext cx="11274552" cy="27432"/>
+          </a:xfrm>
+          <a:prstGeom prst="rect">
+            <a:avLst/>
+          </a:prstGeom>
+          <a:solidFill>
+            <a:srgbClr val="00C6CF"/>
+          </a:solidFill>
+          <a:ln>
+            <a:noFill/>
+          </a:ln>
+        </p:spPr>
+        <p:style>
+          <a:lnRef idx="1">
+            <a:schemeClr val="accent1"/>
+          </a:lnRef>
+          <a:fillRef idx="3">
+            <a:schemeClr val="accent1"/>
+          </a:fillRef>
+          <a:effectRef idx="2">
+            <a:schemeClr val="accent1"/>
+          </a:effectRef>
+          <a:fontRef idx="minor">
+            <a:schemeClr val="lt1"/>
+          </a:fontRef>
+        </p:style>
+        <p:txBody>
+          <a:bodyPr rtlCol="0" anchor="ctr"/>
+          <a:lstStyle/>
+          <a:p>
+            <a:pPr algn="ctr"/>
+          </a:p>
+        </p:txBody>
+      </p:sp>
+      <p:sp>
+        <p:nvSpPr>
+          <p:cNvPr id="6" name="Rectangle 5"/>
+          <p:cNvSpPr/>
+          <p:nvPr/>
+        </p:nvSpPr>
+        <p:spPr>
+          <a:xfrm>
+            <a:off x="411480" y="685800"/>
+            <a:ext cx="5623560" cy="1078992"/>
+          </a:xfrm>
+          <a:prstGeom prst="rect">
+            <a:avLst/>
+          </a:prstGeom>
+          <a:solidFill>
+            <a:srgbClr val="0A1A3A"/>
+          </a:solidFill>
+          <a:ln>
+            <a:noFill/>
+          </a:ln>
+        </p:spPr>
+        <p:style>
+          <a:lnRef idx="1">
+            <a:schemeClr val="accent1"/>
+          </a:lnRef>
+          <a:fillRef idx="3">
+            <a:schemeClr val="accent1"/>
+          </a:fillRef>
+          <a:effectRef idx="2">
+            <a:schemeClr val="accent1"/>
+          </a:effectRef>
+          <a:fontRef idx="minor">
+            <a:schemeClr val="lt1"/>
+          </a:fontRef>
+        </p:style>
+        <p:txBody>
+          <a:bodyPr rtlCol="0" anchor="ctr"/>
+          <a:lstStyle/>
+          <a:p>
+            <a:pPr algn="ctr"/>
+          </a:p>
+        </p:txBody>
+      </p:sp>
+      <p:sp>
+        <p:nvSpPr>
+          <p:cNvPr id="7" name="Rectangle 6"/>
+          <p:cNvSpPr/>
+          <p:nvPr/>
+        </p:nvSpPr>
+        <p:spPr>
+          <a:xfrm>
+            <a:off x="411480" y="685800"/>
+            <a:ext cx="384048" cy="1078992"/>
+          </a:xfrm>
+          <a:prstGeom prst="rect">
+            <a:avLst/>
+          </a:prstGeom>
+          <a:solidFill>
+            <a:srgbClr val="E02B20"/>
+          </a:solidFill>
+          <a:ln>
+            <a:noFill/>
+          </a:ln>
+        </p:spPr>
+        <p:style>
+          <a:lnRef idx="1">
+            <a:schemeClr val="accent1"/>
+          </a:lnRef>
+          <a:fillRef idx="3">
+            <a:schemeClr val="accent1"/>
+          </a:fillRef>
+          <a:effectRef idx="2">
+            <a:schemeClr val="accent1"/>
+          </a:effectRef>
+          <a:fontRef idx="minor">
+            <a:schemeClr val="lt1"/>
+          </a:fontRef>
+        </p:style>
+        <p:txBody>
+          <a:bodyPr rtlCol="0" anchor="ctr"/>
+          <a:lstStyle/>
+          <a:p>
+            <a:pPr algn="ctr"/>
+          </a:p>
+        </p:txBody>
+      </p:sp>
+      <p:sp>
+        <p:nvSpPr>
+          <p:cNvPr id="8" name="TextBox 7"/>
+          <p:cNvSpPr txBox="1"/>
+          <p:nvPr/>
+        </p:nvSpPr>
+        <p:spPr>
+          <a:xfrm>
+            <a:off x="466344" y="1060704"/>
+            <a:ext cx="274320" cy="329184"/>
+          </a:xfrm>
+          <a:prstGeom prst="rect">
+            <a:avLst/>
+          </a:prstGeom>
+          <a:noFill/>
+        </p:spPr>
+        <p:txBody>
+          <a:bodyPr wrap="square">
+            <a:spAutoFit/>
+          </a:bodyPr>
+          <a:lstStyle/>
+          <a:p>
+            <a:pPr algn="ctr"/>
+            <a:r>
+              <a:rPr sz="1400" b="1" i="0">
+                <a:solidFill>
+                  <a:srgbClr val="FFFFFF"/>
+                </a:solidFill>
+                <a:latin typeface="Calibri"/>
+              </a:rPr>
+              <a:t>1</a:t>
+            </a:r>
+          </a:p>
+        </p:txBody>
+      </p:sp>
+      <p:sp>
+        <p:nvSpPr>
+          <p:cNvPr id="9" name="Rectangle 8"/>
+          <p:cNvSpPr/>
+          <p:nvPr/>
+        </p:nvSpPr>
+        <p:spPr>
+          <a:xfrm>
+            <a:off x="868680" y="768096"/>
+            <a:ext cx="1005840" cy="228600"/>
+          </a:xfrm>
+          <a:prstGeom prst="rect">
+            <a:avLst/>
+          </a:prstGeom>
+          <a:solidFill>
+            <a:srgbClr val="E02B20"/>
+          </a:solidFill>
+          <a:ln>
+            <a:noFill/>
+          </a:ln>
+        </p:spPr>
+        <p:style>
+          <a:lnRef idx="1">
+            <a:schemeClr val="accent1"/>
+          </a:lnRef>
+          <a:fillRef idx="3">
+            <a:schemeClr val="accent1"/>
+          </a:fillRef>
+          <a:effectRef idx="2">
+            <a:schemeClr val="accent1"/>
+          </a:effectRef>
+          <a:fontRef idx="minor">
+            <a:schemeClr val="lt1"/>
+          </a:fontRef>
+        </p:style>
+        <p:txBody>
+          <a:bodyPr rtlCol="0" anchor="ctr"/>
+          <a:lstStyle/>
+          <a:p>
+            <a:pPr algn="ctr"/>
+          </a:p>
+        </p:txBody>
+      </p:sp>
+      <p:sp>
+        <p:nvSpPr>
+          <p:cNvPr id="10" name="TextBox 9"/>
+          <p:cNvSpPr txBox="1"/>
+          <p:nvPr/>
+        </p:nvSpPr>
+        <p:spPr>
+          <a:xfrm>
+            <a:off x="914400" y="777240"/>
+            <a:ext cx="914400" cy="201168"/>
+          </a:xfrm>
+          <a:prstGeom prst="rect">
+            <a:avLst/>
+          </a:prstGeom>
+          <a:noFill/>
+        </p:spPr>
+        <p:txBody>
+          <a:bodyPr wrap="square">
+            <a:spAutoFit/>
+          </a:bodyPr>
+          <a:lstStyle/>
+          <a:p>
+            <a:pPr algn="ctr"/>
+            <a:r>
+              <a:rPr sz="800" b="1" i="0">
+                <a:solidFill>
+                  <a:srgbClr val="FFFFFF"/>
+                </a:solidFill>
+                <a:latin typeface="Calibri"/>
+              </a:rPr>
+              <a:t>Due 6/24</a:t>
+            </a:r>
+          </a:p>
+        </p:txBody>
+      </p:sp>
+      <p:sp>
+        <p:nvSpPr>
+          <p:cNvPr id="11" name="TextBox 10"/>
+          <p:cNvSpPr txBox="1"/>
+          <p:nvPr/>
+        </p:nvSpPr>
+        <p:spPr>
+          <a:xfrm>
+            <a:off x="868680" y="1014983"/>
+            <a:ext cx="5074920" cy="274320"/>
+          </a:xfrm>
+          <a:prstGeom prst="rect">
+            <a:avLst/>
+          </a:prstGeom>
+          <a:noFill/>
+        </p:spPr>
+        <p:txBody>
+          <a:bodyPr wrap="square">
+            <a:spAutoFit/>
+          </a:bodyPr>
+          <a:lstStyle/>
+          <a:p>
+            <a:pPr algn="l"/>
+            <a:r>
+              <a:rPr sz="1050" b="1" i="0">
+                <a:solidFill>
+                  <a:srgbClr val="FFFFFF"/>
+                </a:solidFill>
+                <a:latin typeface="Calibri"/>
+              </a:rPr>
+              <a:t>Analyze KB Audit Results Dataset</a:t>
+            </a:r>
+          </a:p>
+        </p:txBody>
+      </p:sp>
+      <p:sp>
+        <p:nvSpPr>
+          <p:cNvPr id="12" name="TextBox 11"/>
+          <p:cNvSpPr txBox="1"/>
+          <p:nvPr/>
+        </p:nvSpPr>
+        <p:spPr>
+          <a:xfrm>
+            <a:off x="868680" y="1289304"/>
+            <a:ext cx="5074920" cy="356616"/>
+          </a:xfrm>
+          <a:prstGeom prst="rect">
+            <a:avLst/>
+          </a:prstGeom>
+          <a:noFill/>
+        </p:spPr>
+        <p:txBody>
+          <a:bodyPr wrap="square">
+            <a:spAutoFit/>
+          </a:bodyPr>
+          <a:lstStyle/>
+          <a:p>
+            <a:pPr algn="l"/>
+            <a:r>
+              <a:rPr sz="900" b="0" i="0">
+                <a:solidFill>
+                  <a:srgbClr val="AABBCC"/>
+                </a:solidFill>
+                <a:latin typeface="Calibri"/>
+              </a:rPr>
+              <a:t>Review the audit output for content priority rankings and interlinking opportunities; use findings to finalize Phase 3a article order.</a:t>
+            </a:r>
+          </a:p>
+        </p:txBody>
+      </p:sp>
+      <p:sp>
+        <p:nvSpPr>
+          <p:cNvPr id="13" name="Rectangle 12"/>
+          <p:cNvSpPr/>
+          <p:nvPr/>
+        </p:nvSpPr>
+        <p:spPr>
+          <a:xfrm>
+            <a:off x="411480" y="1819656"/>
+            <a:ext cx="5623560" cy="1078992"/>
+          </a:xfrm>
+          <a:prstGeom prst="rect">
+            <a:avLst/>
+          </a:prstGeom>
+          <a:solidFill>
+            <a:srgbClr val="0A1A3A"/>
+          </a:solidFill>
+          <a:ln>
+            <a:noFill/>
+          </a:ln>
+        </p:spPr>
+        <p:style>
+          <a:lnRef idx="1">
+            <a:schemeClr val="accent1"/>
+          </a:lnRef>
+          <a:fillRef idx="3">
+            <a:schemeClr val="accent1"/>
+          </a:fillRef>
+          <a:effectRef idx="2">
+            <a:schemeClr val="accent1"/>
+          </a:effectRef>
+          <a:fontRef idx="minor">
+            <a:schemeClr val="lt1"/>
+          </a:fontRef>
+        </p:style>
+        <p:txBody>
+          <a:bodyPr rtlCol="0" anchor="ctr"/>
+          <a:lstStyle/>
+          <a:p>
+            <a:pPr algn="ctr"/>
+          </a:p>
+        </p:txBody>
+      </p:sp>
+      <p:sp>
+        <p:nvSpPr>
+          <p:cNvPr id="14" name="Rectangle 13"/>
+          <p:cNvSpPr/>
+          <p:nvPr/>
+        </p:nvSpPr>
+        <p:spPr>
+          <a:xfrm>
+            <a:off x="411480" y="1819656"/>
+            <a:ext cx="384048" cy="1078992"/>
+          </a:xfrm>
+          <a:prstGeom prst="rect">
+            <a:avLst/>
+          </a:prstGeom>
+          <a:solidFill>
+            <a:srgbClr val="FF6B00"/>
+          </a:solidFill>
+          <a:ln>
+            <a:noFill/>
+          </a:ln>
+        </p:spPr>
+        <p:style>
+          <a:lnRef idx="1">
+            <a:schemeClr val="accent1"/>
+          </a:lnRef>
+          <a:fillRef idx="3">
+            <a:schemeClr val="accent1"/>
+          </a:fillRef>
+          <a:effectRef idx="2">
+            <a:schemeClr val="accent1"/>
+          </a:effectRef>
+          <a:fontRef idx="minor">
+            <a:schemeClr val="lt1"/>
+          </a:fontRef>
+        </p:style>
+        <p:txBody>
+          <a:bodyPr rtlCol="0" anchor="ctr"/>
+          <a:lstStyle/>
+          <a:p>
+            <a:pPr algn="ctr"/>
+          </a:p>
+        </p:txBody>
+      </p:sp>
+      <p:sp>
+        <p:nvSpPr>
+          <p:cNvPr id="15" name="TextBox 14"/>
+          <p:cNvSpPr txBox="1"/>
+          <p:nvPr/>
+        </p:nvSpPr>
+        <p:spPr>
+          <a:xfrm>
+            <a:off x="466344" y="2194560"/>
+            <a:ext cx="274320" cy="329184"/>
+          </a:xfrm>
+          <a:prstGeom prst="rect">
+            <a:avLst/>
+          </a:prstGeom>
+          <a:noFill/>
+        </p:spPr>
+        <p:txBody>
+          <a:bodyPr wrap="square">
+            <a:spAutoFit/>
+          </a:bodyPr>
+          <a:lstStyle/>
+          <a:p>
+            <a:pPr algn="ctr"/>
+            <a:r>
+              <a:rPr sz="1400" b="1" i="0">
+                <a:solidFill>
+                  <a:srgbClr val="FFFFFF"/>
+                </a:solidFill>
+                <a:latin typeface="Calibri"/>
+              </a:rPr>
+              <a:t>2</a:t>
+            </a:r>
+          </a:p>
+        </p:txBody>
+      </p:sp>
+      <p:sp>
+        <p:nvSpPr>
+          <p:cNvPr id="16" name="Rectangle 15"/>
+          <p:cNvSpPr/>
+          <p:nvPr/>
+        </p:nvSpPr>
+        <p:spPr>
+          <a:xfrm>
+            <a:off x="868680" y="1901952"/>
+            <a:ext cx="1005840" cy="228600"/>
+          </a:xfrm>
+          <a:prstGeom prst="rect">
+            <a:avLst/>
+          </a:prstGeom>
+          <a:solidFill>
+            <a:srgbClr val="FF6B00"/>
+          </a:solidFill>
+          <a:ln>
+            <a:noFill/>
+          </a:ln>
+        </p:spPr>
+        <p:style>
+          <a:lnRef idx="1">
+            <a:schemeClr val="accent1"/>
+          </a:lnRef>
+          <a:fillRef idx="3">
+            <a:schemeClr val="accent1"/>
+          </a:fillRef>
+          <a:effectRef idx="2">
+            <a:schemeClr val="accent1"/>
+          </a:effectRef>
+          <a:fontRef idx="minor">
+            <a:schemeClr val="lt1"/>
+          </a:fontRef>
+        </p:style>
+        <p:txBody>
+          <a:bodyPr rtlCol="0" anchor="ctr"/>
+          <a:lstStyle/>
+          <a:p>
+            <a:pPr algn="ctr"/>
+          </a:p>
+        </p:txBody>
+      </p:sp>
+      <p:sp>
+        <p:nvSpPr>
+          <p:cNvPr id="17" name="TextBox 16"/>
+          <p:cNvSpPr txBox="1"/>
+          <p:nvPr/>
+        </p:nvSpPr>
+        <p:spPr>
+          <a:xfrm>
+            <a:off x="914400" y="1911095"/>
+            <a:ext cx="914400" cy="201168"/>
+          </a:xfrm>
+          <a:prstGeom prst="rect">
+            <a:avLst/>
+          </a:prstGeom>
+          <a:noFill/>
+        </p:spPr>
+        <p:txBody>
+          <a:bodyPr wrap="square">
+            <a:spAutoFit/>
+          </a:bodyPr>
+          <a:lstStyle/>
+          <a:p>
+            <a:pPr algn="ctr"/>
+            <a:r>
+              <a:rPr sz="800" b="1" i="0">
+                <a:solidFill>
+                  <a:srgbClr val="FFFFFF"/>
+                </a:solidFill>
+                <a:latin typeface="Calibri"/>
+              </a:rPr>
+              <a:t>Team Sync</a:t>
+            </a:r>
+          </a:p>
+        </p:txBody>
+      </p:sp>
+      <p:sp>
+        <p:nvSpPr>
+          <p:cNvPr id="18" name="TextBox 17"/>
+          <p:cNvSpPr txBox="1"/>
+          <p:nvPr/>
+        </p:nvSpPr>
+        <p:spPr>
+          <a:xfrm>
+            <a:off x="868680" y="2148840"/>
+            <a:ext cx="5074920" cy="274320"/>
+          </a:xfrm>
+          <a:prstGeom prst="rect">
+            <a:avLst/>
+          </a:prstGeom>
+          <a:noFill/>
+        </p:spPr>
+        <p:txBody>
+          <a:bodyPr wrap="square">
+            <a:spAutoFit/>
+          </a:bodyPr>
+          <a:lstStyle/>
+          <a:p>
+            <a:pPr algn="l"/>
+            <a:r>
+              <a:rPr sz="1050" b="1" i="0">
+                <a:solidFill>
+                  <a:srgbClr val="FFFFFF"/>
+                </a:solidFill>
+                <a:latin typeface="Calibri"/>
+              </a:rPr>
+              <a:t>Approve Plan &amp; Align on Pillar Names</a:t>
+            </a:r>
+          </a:p>
+        </p:txBody>
+      </p:sp>
+      <p:sp>
+        <p:nvSpPr>
+          <p:cNvPr id="19" name="TextBox 18"/>
+          <p:cNvSpPr txBox="1"/>
+          <p:nvPr/>
+        </p:nvSpPr>
+        <p:spPr>
+          <a:xfrm>
+            <a:off x="868680" y="2423160"/>
+            <a:ext cx="5074920" cy="356616"/>
+          </a:xfrm>
+          <a:prstGeom prst="rect">
+            <a:avLst/>
+          </a:prstGeom>
+          <a:noFill/>
+        </p:spPr>
+        <p:txBody>
+          <a:bodyPr wrap="square">
+            <a:spAutoFit/>
+          </a:bodyPr>
+          <a:lstStyle/>
+          <a:p>
+            <a:pPr algn="l"/>
+            <a:r>
+              <a:rPr sz="900" b="0" i="0">
+                <a:solidFill>
+                  <a:srgbClr val="AABBCC"/>
+                </a:solidFill>
+                <a:latin typeface="Calibri"/>
+              </a:rPr>
+              <a:t>Walk team through the restructure plan; get formal approval; lock final names for all 12 pillars before any content creation begins.</a:t>
+            </a:r>
+          </a:p>
+        </p:txBody>
+      </p:sp>
+      <p:sp>
+        <p:nvSpPr>
+          <p:cNvPr id="20" name="Rectangle 19"/>
+          <p:cNvSpPr/>
+          <p:nvPr/>
+        </p:nvSpPr>
+        <p:spPr>
+          <a:xfrm>
+            <a:off x="411480" y="2953512"/>
+            <a:ext cx="5623560" cy="1078992"/>
+          </a:xfrm>
+          <a:prstGeom prst="rect">
+            <a:avLst/>
+          </a:prstGeom>
+          <a:solidFill>
+            <a:srgbClr val="0A1A3A"/>
+          </a:solidFill>
+          <a:ln>
+            <a:noFill/>
+          </a:ln>
+        </p:spPr>
+        <p:style>
+          <a:lnRef idx="1">
+            <a:schemeClr val="accent1"/>
+          </a:lnRef>
+          <a:fillRef idx="3">
+            <a:schemeClr val="accent1"/>
+          </a:fillRef>
+          <a:effectRef idx="2">
+            <a:schemeClr val="accent1"/>
+          </a:effectRef>
+          <a:fontRef idx="minor">
+            <a:schemeClr val="lt1"/>
+          </a:fontRef>
+        </p:style>
+        <p:txBody>
+          <a:bodyPr rtlCol="0" anchor="ctr"/>
+          <a:lstStyle/>
+          <a:p>
+            <a:pPr algn="ctr"/>
+          </a:p>
+        </p:txBody>
+      </p:sp>
+      <p:sp>
+        <p:nvSpPr>
+          <p:cNvPr id="21" name="Rectangle 20"/>
+          <p:cNvSpPr/>
+          <p:nvPr/>
+        </p:nvSpPr>
+        <p:spPr>
+          <a:xfrm>
+            <a:off x="411480" y="2953512"/>
+            <a:ext cx="384048" cy="1078992"/>
+          </a:xfrm>
+          <a:prstGeom prst="rect">
+            <a:avLst/>
+          </a:prstGeom>
+          <a:solidFill>
+            <a:srgbClr val="C8A000"/>
+          </a:solidFill>
+          <a:ln>
+            <a:noFill/>
+          </a:ln>
+        </p:spPr>
+        <p:style>
+          <a:lnRef idx="1">
+            <a:schemeClr val="accent1"/>
+          </a:lnRef>
+          <a:fillRef idx="3">
+            <a:schemeClr val="accent1"/>
+          </a:fillRef>
+          <a:effectRef idx="2">
+            <a:schemeClr val="accent1"/>
+          </a:effectRef>
+          <a:fontRef idx="minor">
+            <a:schemeClr val="lt1"/>
+          </a:fontRef>
+        </p:style>
+        <p:txBody>
+          <a:bodyPr rtlCol="0" anchor="ctr"/>
+          <a:lstStyle/>
+          <a:p>
+            <a:pPr algn="ctr"/>
+          </a:p>
+        </p:txBody>
+      </p:sp>
+      <p:sp>
+        <p:nvSpPr>
+          <p:cNvPr id="22" name="TextBox 21"/>
+          <p:cNvSpPr txBox="1"/>
+          <p:nvPr/>
+        </p:nvSpPr>
+        <p:spPr>
+          <a:xfrm>
+            <a:off x="466344" y="3328415"/>
+            <a:ext cx="274320" cy="329184"/>
+          </a:xfrm>
+          <a:prstGeom prst="rect">
+            <a:avLst/>
+          </a:prstGeom>
+          <a:noFill/>
+        </p:spPr>
+        <p:txBody>
+          <a:bodyPr wrap="square">
+            <a:spAutoFit/>
+          </a:bodyPr>
+          <a:lstStyle/>
+          <a:p>
+            <a:pPr algn="ctr"/>
+            <a:r>
+              <a:rPr sz="1400" b="1" i="0">
+                <a:solidFill>
+                  <a:srgbClr val="FFFFFF"/>
+                </a:solidFill>
+                <a:latin typeface="Calibri"/>
+              </a:rPr>
+              <a:t>3</a:t>
+            </a:r>
+          </a:p>
+        </p:txBody>
+      </p:sp>
+      <p:sp>
+        <p:nvSpPr>
+          <p:cNvPr id="23" name="Rectangle 22"/>
+          <p:cNvSpPr/>
+          <p:nvPr/>
+        </p:nvSpPr>
+        <p:spPr>
+          <a:xfrm>
+            <a:off x="868680" y="3035808"/>
+            <a:ext cx="1005840" cy="228600"/>
+          </a:xfrm>
+          <a:prstGeom prst="rect">
+            <a:avLst/>
+          </a:prstGeom>
+          <a:solidFill>
+            <a:srgbClr val="C8A000"/>
+          </a:solidFill>
+          <a:ln>
+            <a:noFill/>
+          </a:ln>
+        </p:spPr>
+        <p:style>
+          <a:lnRef idx="1">
+            <a:schemeClr val="accent1"/>
+          </a:lnRef>
+          <a:fillRef idx="3">
+            <a:schemeClr val="accent1"/>
+          </a:fillRef>
+          <a:effectRef idx="2">
+            <a:schemeClr val="accent1"/>
+          </a:effectRef>
+          <a:fontRef idx="minor">
+            <a:schemeClr val="lt1"/>
+          </a:fontRef>
+        </p:style>
+        <p:txBody>
+          <a:bodyPr rtlCol="0" anchor="ctr"/>
+          <a:lstStyle/>
+          <a:p>
+            <a:pPr algn="ctr"/>
+          </a:p>
+        </p:txBody>
+      </p:sp>
+      <p:sp>
+        <p:nvSpPr>
+          <p:cNvPr id="24" name="TextBox 23"/>
+          <p:cNvSpPr txBox="1"/>
+          <p:nvPr/>
+        </p:nvSpPr>
+        <p:spPr>
+          <a:xfrm>
+            <a:off x="914400" y="3044952"/>
+            <a:ext cx="914400" cy="201168"/>
+          </a:xfrm>
+          <a:prstGeom prst="rect">
+            <a:avLst/>
+          </a:prstGeom>
+          <a:noFill/>
+        </p:spPr>
+        <p:txBody>
+          <a:bodyPr wrap="square">
+            <a:spAutoFit/>
+          </a:bodyPr>
+          <a:lstStyle/>
+          <a:p>
+            <a:pPr algn="ctr"/>
+            <a:r>
+              <a:rPr sz="800" b="1" i="0">
+                <a:solidFill>
+                  <a:srgbClr val="FFFFFF"/>
+                </a:solidFill>
+                <a:latin typeface="Calibri"/>
+              </a:rPr>
+              <a:t>Internal</a:t>
+            </a:r>
+          </a:p>
+        </p:txBody>
+      </p:sp>
+      <p:sp>
+        <p:nvSpPr>
+          <p:cNvPr id="25" name="TextBox 24"/>
+          <p:cNvSpPr txBox="1"/>
+          <p:nvPr/>
+        </p:nvSpPr>
+        <p:spPr>
+          <a:xfrm>
+            <a:off x="868680" y="3282696"/>
+            <a:ext cx="5074920" cy="274320"/>
+          </a:xfrm>
+          <a:prstGeom prst="rect">
+            <a:avLst/>
+          </a:prstGeom>
+          <a:noFill/>
+        </p:spPr>
+        <p:txBody>
+          <a:bodyPr wrap="square">
+            <a:spAutoFit/>
+          </a:bodyPr>
+          <a:lstStyle/>
+          <a:p>
+            <a:pPr algn="l"/>
+            <a:r>
+              <a:rPr sz="1050" b="1" i="0">
+                <a:solidFill>
+                  <a:srgbClr val="FFFFFF"/>
+                </a:solidFill>
+                <a:latin typeface="Calibri"/>
+              </a:rPr>
+              <a:t>Understand &amp; Document the AI-Generated Artifacts</a:t>
+            </a:r>
+          </a:p>
+        </p:txBody>
+      </p:sp>
+      <p:sp>
+        <p:nvSpPr>
+          <p:cNvPr id="26" name="TextBox 25"/>
+          <p:cNvSpPr txBox="1"/>
+          <p:nvPr/>
+        </p:nvSpPr>
+        <p:spPr>
+          <a:xfrm>
+            <a:off x="868680" y="3557016"/>
+            <a:ext cx="5074920" cy="356616"/>
+          </a:xfrm>
+          <a:prstGeom prst="rect">
+            <a:avLst/>
+          </a:prstGeom>
+          <a:noFill/>
+        </p:spPr>
+        <p:txBody>
+          <a:bodyPr wrap="square">
+            <a:spAutoFit/>
+          </a:bodyPr>
+          <a:lstStyle/>
+          <a:p>
+            <a:pPr algn="l"/>
+            <a:r>
+              <a:rPr sz="900" b="0" i="0">
+                <a:solidFill>
+                  <a:srgbClr val="AABBCC"/>
+                </a:solidFill>
+                <a:latin typeface="Calibri"/>
+              </a:rPr>
+              <a:t>Review the classification JSONs and gap-analysis outputs for transparency; make sure the team understands what the scripts produced and why.</a:t>
+            </a:r>
+          </a:p>
+        </p:txBody>
+      </p:sp>
+      <p:sp>
+        <p:nvSpPr>
+          <p:cNvPr id="27" name="Rectangle 26"/>
+          <p:cNvSpPr/>
+          <p:nvPr/>
+        </p:nvSpPr>
+        <p:spPr>
+          <a:xfrm>
+            <a:off x="411480" y="4087368"/>
+            <a:ext cx="5623560" cy="1078992"/>
+          </a:xfrm>
+          <a:prstGeom prst="rect">
+            <a:avLst/>
+          </a:prstGeom>
+          <a:solidFill>
+            <a:srgbClr val="0A1A3A"/>
+          </a:solidFill>
+          <a:ln>
+            <a:noFill/>
+          </a:ln>
+        </p:spPr>
+        <p:style>
+          <a:lnRef idx="1">
+            <a:schemeClr val="accent1"/>
+          </a:lnRef>
+          <a:fillRef idx="3">
+            <a:schemeClr val="accent1"/>
+          </a:fillRef>
+          <a:effectRef idx="2">
+            <a:schemeClr val="accent1"/>
+          </a:effectRef>
+          <a:fontRef idx="minor">
+            <a:schemeClr val="lt1"/>
+          </a:fontRef>
+        </p:style>
+        <p:txBody>
+          <a:bodyPr rtlCol="0" anchor="ctr"/>
+          <a:lstStyle/>
+          <a:p>
+            <a:pPr algn="ctr"/>
+          </a:p>
+        </p:txBody>
+      </p:sp>
+      <p:sp>
+        <p:nvSpPr>
+          <p:cNvPr id="28" name="Rectangle 27"/>
+          <p:cNvSpPr/>
+          <p:nvPr/>
+        </p:nvSpPr>
+        <p:spPr>
+          <a:xfrm>
+            <a:off x="411480" y="4087368"/>
+            <a:ext cx="384048" cy="1078992"/>
+          </a:xfrm>
+          <a:prstGeom prst="rect">
+            <a:avLst/>
+          </a:prstGeom>
+          <a:solidFill>
+            <a:srgbClr val="00C6CF"/>
+          </a:solidFill>
+          <a:ln>
+            <a:noFill/>
+          </a:ln>
+        </p:spPr>
+        <p:style>
+          <a:lnRef idx="1">
+            <a:schemeClr val="accent1"/>
+          </a:lnRef>
+          <a:fillRef idx="3">
+            <a:schemeClr val="accent1"/>
+          </a:fillRef>
+          <a:effectRef idx="2">
+            <a:schemeClr val="accent1"/>
+          </a:effectRef>
+          <a:fontRef idx="minor">
+            <a:schemeClr val="lt1"/>
+          </a:fontRef>
+        </p:style>
+        <p:txBody>
+          <a:bodyPr rtlCol="0" anchor="ctr"/>
+          <a:lstStyle/>
+          <a:p>
+            <a:pPr algn="ctr"/>
+          </a:p>
+        </p:txBody>
+      </p:sp>
+      <p:sp>
+        <p:nvSpPr>
+          <p:cNvPr id="29" name="TextBox 28"/>
+          <p:cNvSpPr txBox="1"/>
+          <p:nvPr/>
+        </p:nvSpPr>
+        <p:spPr>
+          <a:xfrm>
+            <a:off x="466344" y="4462272"/>
+            <a:ext cx="274320" cy="329184"/>
+          </a:xfrm>
+          <a:prstGeom prst="rect">
+            <a:avLst/>
+          </a:prstGeom>
+          <a:noFill/>
+        </p:spPr>
+        <p:txBody>
+          <a:bodyPr wrap="square">
+            <a:spAutoFit/>
+          </a:bodyPr>
+          <a:lstStyle/>
+          <a:p>
+            <a:pPr algn="ctr"/>
+            <a:r>
+              <a:rPr sz="1400" b="1" i="0">
+                <a:solidFill>
+                  <a:srgbClr val="FFFFFF"/>
+                </a:solidFill>
+                <a:latin typeface="Calibri"/>
+              </a:rPr>
+              <a:t>4</a:t>
+            </a:r>
+          </a:p>
+        </p:txBody>
+      </p:sp>
+      <p:sp>
+        <p:nvSpPr>
+          <p:cNvPr id="30" name="Rectangle 29"/>
+          <p:cNvSpPr/>
+          <p:nvPr/>
+        </p:nvSpPr>
+        <p:spPr>
+          <a:xfrm>
+            <a:off x="868680" y="4169663"/>
+            <a:ext cx="1005840" cy="228600"/>
+          </a:xfrm>
+          <a:prstGeom prst="rect">
+            <a:avLst/>
+          </a:prstGeom>
+          <a:solidFill>
+            <a:srgbClr val="00C6CF"/>
+          </a:solidFill>
+          <a:ln>
+            <a:noFill/>
+          </a:ln>
+        </p:spPr>
+        <p:style>
+          <a:lnRef idx="1">
+            <a:schemeClr val="accent1"/>
+          </a:lnRef>
+          <a:fillRef idx="3">
+            <a:schemeClr val="accent1"/>
+          </a:fillRef>
+          <a:effectRef idx="2">
+            <a:schemeClr val="accent1"/>
+          </a:effectRef>
+          <a:fontRef idx="minor">
+            <a:schemeClr val="lt1"/>
+          </a:fontRef>
+        </p:style>
+        <p:txBody>
+          <a:bodyPr rtlCol="0" anchor="ctr"/>
+          <a:lstStyle/>
+          <a:p>
+            <a:pPr algn="ctr"/>
+          </a:p>
+        </p:txBody>
+      </p:sp>
+      <p:sp>
+        <p:nvSpPr>
+          <p:cNvPr id="31" name="TextBox 30"/>
+          <p:cNvSpPr txBox="1"/>
+          <p:nvPr/>
+        </p:nvSpPr>
+        <p:spPr>
+          <a:xfrm>
+            <a:off x="914400" y="4178807"/>
+            <a:ext cx="914400" cy="201168"/>
+          </a:xfrm>
+          <a:prstGeom prst="rect">
+            <a:avLst/>
+          </a:prstGeom>
+          <a:noFill/>
+        </p:spPr>
+        <p:txBody>
+          <a:bodyPr wrap="square">
+            <a:spAutoFit/>
+          </a:bodyPr>
+          <a:lstStyle/>
+          <a:p>
+            <a:pPr algn="ctr"/>
+            <a:r>
+              <a:rPr sz="800" b="1" i="0">
+                <a:solidFill>
+                  <a:srgbClr val="FFFFFF"/>
+                </a:solidFill>
+                <a:latin typeface="Calibri"/>
+              </a:rPr>
+              <a:t>Intake</a:t>
+            </a:r>
+          </a:p>
+        </p:txBody>
+      </p:sp>
+      <p:sp>
+        <p:nvSpPr>
+          <p:cNvPr id="32" name="TextBox 31"/>
+          <p:cNvSpPr txBox="1"/>
+          <p:nvPr/>
+        </p:nvSpPr>
+        <p:spPr>
+          <a:xfrm>
+            <a:off x="868680" y="4416552"/>
+            <a:ext cx="5074920" cy="274320"/>
+          </a:xfrm>
+          <a:prstGeom prst="rect">
+            <a:avLst/>
+          </a:prstGeom>
+          <a:noFill/>
+        </p:spPr>
+        <p:txBody>
+          <a:bodyPr wrap="square">
+            <a:spAutoFit/>
+          </a:bodyPr>
+          <a:lstStyle/>
+          <a:p>
+            <a:pPr algn="l"/>
+            <a:r>
+              <a:rPr sz="1050" b="1" i="0">
+                <a:solidFill>
+                  <a:srgbClr val="FFFFFF"/>
+                </a:solidFill>
+                <a:latin typeface="Calibri"/>
+              </a:rPr>
+              <a:t>Integrate Leema's Feedback on Connectors Organization</a:t>
+            </a:r>
+          </a:p>
+        </p:txBody>
+      </p:sp>
+      <p:sp>
+        <p:nvSpPr>
+          <p:cNvPr id="33" name="TextBox 32"/>
+          <p:cNvSpPr txBox="1"/>
+          <p:nvPr/>
+        </p:nvSpPr>
+        <p:spPr>
+          <a:xfrm>
+            <a:off x="868680" y="4690872"/>
+            <a:ext cx="5074920" cy="356616"/>
+          </a:xfrm>
+          <a:prstGeom prst="rect">
+            <a:avLst/>
+          </a:prstGeom>
+          <a:noFill/>
+        </p:spPr>
+        <p:txBody>
+          <a:bodyPr wrap="square">
+            <a:spAutoFit/>
+          </a:bodyPr>
+          <a:lstStyle/>
+          <a:p>
+            <a:pPr algn="l"/>
+            <a:r>
+              <a:rPr sz="900" b="0" i="0">
+                <a:solidFill>
+                  <a:srgbClr val="AABBCC"/>
+                </a:solidFill>
+                <a:latin typeface="Calibri"/>
+              </a:rPr>
+              <a:t>Incorporate workshop and stakeholder feedback into the Connect &amp; Bring In Data pillar structure before the nav rebuild begins.</a:t>
+            </a:r>
+          </a:p>
+        </p:txBody>
+      </p:sp>
+      <p:sp>
+        <p:nvSpPr>
+          <p:cNvPr id="34" name="Rectangle 33"/>
+          <p:cNvSpPr/>
+          <p:nvPr/>
+        </p:nvSpPr>
+        <p:spPr>
+          <a:xfrm>
+            <a:off x="411480" y="5221224"/>
+            <a:ext cx="5623560" cy="1078992"/>
+          </a:xfrm>
+          <a:prstGeom prst="rect">
+            <a:avLst/>
+          </a:prstGeom>
+          <a:solidFill>
+            <a:srgbClr val="0A1A3A"/>
+          </a:solidFill>
+          <a:ln>
+            <a:noFill/>
+          </a:ln>
+        </p:spPr>
+        <p:style>
+          <a:lnRef idx="1">
+            <a:schemeClr val="accent1"/>
+          </a:lnRef>
+          <a:fillRef idx="3">
+            <a:schemeClr val="accent1"/>
+          </a:fillRef>
+          <a:effectRef idx="2">
+            <a:schemeClr val="accent1"/>
+          </a:effectRef>
+          <a:fontRef idx="minor">
+            <a:schemeClr val="lt1"/>
+          </a:fontRef>
+        </p:style>
+        <p:txBody>
+          <a:bodyPr rtlCol="0" anchor="ctr"/>
+          <a:lstStyle/>
+          <a:p>
+            <a:pPr algn="ctr"/>
+          </a:p>
+        </p:txBody>
+      </p:sp>
+      <p:sp>
+        <p:nvSpPr>
+          <p:cNvPr id="35" name="Rectangle 34"/>
+          <p:cNvSpPr/>
+          <p:nvPr/>
+        </p:nvSpPr>
+        <p:spPr>
+          <a:xfrm>
+            <a:off x="411480" y="5221224"/>
+            <a:ext cx="384048" cy="1078992"/>
+          </a:xfrm>
+          <a:prstGeom prst="rect">
+            <a:avLst/>
+          </a:prstGeom>
+          <a:solidFill>
+            <a:srgbClr val="006BC5"/>
+          </a:solidFill>
+          <a:ln>
+            <a:noFill/>
+          </a:ln>
+        </p:spPr>
+        <p:style>
+          <a:lnRef idx="1">
+            <a:schemeClr val="accent1"/>
+          </a:lnRef>
+          <a:fillRef idx="3">
+            <a:schemeClr val="accent1"/>
+          </a:fillRef>
+          <a:effectRef idx="2">
+            <a:schemeClr val="accent1"/>
+          </a:effectRef>
+          <a:fontRef idx="minor">
+            <a:schemeClr val="lt1"/>
+          </a:fontRef>
+        </p:style>
+        <p:txBody>
+          <a:bodyPr rtlCol="0" anchor="ctr"/>
+          <a:lstStyle/>
+          <a:p>
+            <a:pPr algn="ctr"/>
+          </a:p>
+        </p:txBody>
+      </p:sp>
+      <p:sp>
+        <p:nvSpPr>
+          <p:cNvPr id="36" name="TextBox 35"/>
+          <p:cNvSpPr txBox="1"/>
+          <p:nvPr/>
+        </p:nvSpPr>
+        <p:spPr>
+          <a:xfrm>
+            <a:off x="466344" y="5596128"/>
+            <a:ext cx="274320" cy="329184"/>
+          </a:xfrm>
+          <a:prstGeom prst="rect">
+            <a:avLst/>
+          </a:prstGeom>
+          <a:noFill/>
+        </p:spPr>
+        <p:txBody>
+          <a:bodyPr wrap="square">
+            <a:spAutoFit/>
+          </a:bodyPr>
+          <a:lstStyle/>
+          <a:p>
+            <a:pPr algn="ctr"/>
+            <a:r>
+              <a:rPr sz="1400" b="1" i="0">
+                <a:solidFill>
+                  <a:srgbClr val="FFFFFF"/>
+                </a:solidFill>
+                <a:latin typeface="Calibri"/>
+              </a:rPr>
+              <a:t>5</a:t>
+            </a:r>
+          </a:p>
+        </p:txBody>
+      </p:sp>
+      <p:sp>
+        <p:nvSpPr>
+          <p:cNvPr id="37" name="Rectangle 36"/>
+          <p:cNvSpPr/>
+          <p:nvPr/>
+        </p:nvSpPr>
+        <p:spPr>
+          <a:xfrm>
+            <a:off x="868680" y="5303520"/>
+            <a:ext cx="1005840" cy="228600"/>
+          </a:xfrm>
+          <a:prstGeom prst="rect">
+            <a:avLst/>
+          </a:prstGeom>
+          <a:solidFill>
+            <a:srgbClr val="006BC5"/>
+          </a:solidFill>
+          <a:ln>
+            <a:noFill/>
+          </a:ln>
+        </p:spPr>
+        <p:style>
+          <a:lnRef idx="1">
+            <a:schemeClr val="accent1"/>
+          </a:lnRef>
+          <a:fillRef idx="3">
+            <a:schemeClr val="accent1"/>
+          </a:fillRef>
+          <a:effectRef idx="2">
+            <a:schemeClr val="accent1"/>
+          </a:effectRef>
+          <a:fontRef idx="minor">
+            <a:schemeClr val="lt1"/>
+          </a:fontRef>
+        </p:style>
+        <p:txBody>
+          <a:bodyPr rtlCol="0" anchor="ctr"/>
+          <a:lstStyle/>
+          <a:p>
+            <a:pPr algn="ctr"/>
+          </a:p>
+        </p:txBody>
+      </p:sp>
+      <p:sp>
+        <p:nvSpPr>
+          <p:cNvPr id="38" name="TextBox 37"/>
+          <p:cNvSpPr txBox="1"/>
+          <p:nvPr/>
+        </p:nvSpPr>
+        <p:spPr>
+          <a:xfrm>
+            <a:off x="914400" y="5312664"/>
+            <a:ext cx="914400" cy="201168"/>
+          </a:xfrm>
+          <a:prstGeom prst="rect">
+            <a:avLst/>
+          </a:prstGeom>
+          <a:noFill/>
+        </p:spPr>
+        <p:txBody>
+          <a:bodyPr wrap="square">
+            <a:spAutoFit/>
+          </a:bodyPr>
+          <a:lstStyle/>
+          <a:p>
+            <a:pPr algn="ctr"/>
+            <a:r>
+              <a:rPr sz="800" b="1" i="0">
+                <a:solidFill>
+                  <a:srgbClr val="FFFFFF"/>
+                </a:solidFill>
+                <a:latin typeface="Calibri"/>
+              </a:rPr>
+              <a:t>Phase 3 Prep</a:t>
+            </a:r>
+          </a:p>
+        </p:txBody>
+      </p:sp>
+      <p:sp>
+        <p:nvSpPr>
+          <p:cNvPr id="39" name="TextBox 38"/>
+          <p:cNvSpPr txBox="1"/>
+          <p:nvPr/>
+        </p:nvSpPr>
+        <p:spPr>
+          <a:xfrm>
+            <a:off x="868680" y="5550408"/>
+            <a:ext cx="5074920" cy="274320"/>
+          </a:xfrm>
+          <a:prstGeom prst="rect">
+            <a:avLst/>
+          </a:prstGeom>
+          <a:noFill/>
+        </p:spPr>
+        <p:txBody>
+          <a:bodyPr wrap="square">
+            <a:spAutoFit/>
+          </a:bodyPr>
+          <a:lstStyle/>
+          <a:p>
+            <a:pPr algn="l"/>
+            <a:r>
+              <a:rPr sz="1050" b="1" i="0">
+                <a:solidFill>
+                  <a:srgbClr val="FFFFFF"/>
+                </a:solidFill>
+                <a:latin typeface="Calibri"/>
+              </a:rPr>
+              <a:t>Restructure Test Run — Generate &amp; Validate Gap-Fill List</a:t>
+            </a:r>
+          </a:p>
+        </p:txBody>
+      </p:sp>
+      <p:sp>
+        <p:nvSpPr>
+          <p:cNvPr id="40" name="TextBox 39"/>
+          <p:cNvSpPr txBox="1"/>
+          <p:nvPr/>
+        </p:nvSpPr>
+        <p:spPr>
+          <a:xfrm>
+            <a:off x="868680" y="5824728"/>
+            <a:ext cx="5074920" cy="356616"/>
+          </a:xfrm>
+          <a:prstGeom prst="rect">
+            <a:avLst/>
+          </a:prstGeom>
+          <a:noFill/>
+        </p:spPr>
+        <p:txBody>
+          <a:bodyPr wrap="square">
+            <a:spAutoFit/>
+          </a:bodyPr>
+          <a:lstStyle/>
+          <a:p>
+            <a:pPr algn="l"/>
+            <a:r>
+              <a:rPr sz="900" b="0" i="0">
+                <a:solidFill>
+                  <a:srgbClr val="AABBCC"/>
+                </a:solidFill>
+                <a:latin typeface="Calibri"/>
+              </a:rPr>
+              <a:t>Run a scoped pilot: generate, organize, and validate the full gap-fill article list against the IA spec to confirm scope and surface any surprises.</a:t>
+            </a:r>
+          </a:p>
+        </p:txBody>
+      </p:sp>
+      <p:sp>
+        <p:nvSpPr>
+          <p:cNvPr id="41" name="Rectangle 40"/>
+          <p:cNvSpPr/>
+          <p:nvPr/>
+        </p:nvSpPr>
+        <p:spPr>
+          <a:xfrm>
+            <a:off x="6153912" y="685800"/>
+            <a:ext cx="5623560" cy="1362456"/>
+          </a:xfrm>
+          <a:prstGeom prst="rect">
+            <a:avLst/>
+          </a:prstGeom>
+          <a:solidFill>
+            <a:srgbClr val="0A1A3A"/>
+          </a:solidFill>
+          <a:ln>
+            <a:noFill/>
+          </a:ln>
+        </p:spPr>
+        <p:style>
+          <a:lnRef idx="1">
+            <a:schemeClr val="accent1"/>
+          </a:lnRef>
+          <a:fillRef idx="3">
+            <a:schemeClr val="accent1"/>
+          </a:fillRef>
+          <a:effectRef idx="2">
+            <a:schemeClr val="accent1"/>
+          </a:effectRef>
+          <a:fontRef idx="minor">
+            <a:schemeClr val="lt1"/>
+          </a:fontRef>
+        </p:style>
+        <p:txBody>
+          <a:bodyPr rtlCol="0" anchor="ctr"/>
+          <a:lstStyle/>
+          <a:p>
+            <a:pPr algn="ctr"/>
+          </a:p>
+        </p:txBody>
+      </p:sp>
+      <p:sp>
+        <p:nvSpPr>
+          <p:cNvPr id="42" name="Rectangle 41"/>
+          <p:cNvSpPr/>
+          <p:nvPr/>
+        </p:nvSpPr>
+        <p:spPr>
+          <a:xfrm>
+            <a:off x="6153912" y="685800"/>
+            <a:ext cx="384048" cy="1362456"/>
+          </a:xfrm>
+          <a:prstGeom prst="rect">
+            <a:avLst/>
+          </a:prstGeom>
+          <a:solidFill>
+            <a:srgbClr val="006BC5"/>
+          </a:solidFill>
+          <a:ln>
+            <a:noFill/>
+          </a:ln>
+        </p:spPr>
+        <p:style>
+          <a:lnRef idx="1">
+            <a:schemeClr val="accent1"/>
+          </a:lnRef>
+          <a:fillRef idx="3">
+            <a:schemeClr val="accent1"/>
+          </a:fillRef>
+          <a:effectRef idx="2">
+            <a:schemeClr val="accent1"/>
+          </a:effectRef>
+          <a:fontRef idx="minor">
+            <a:schemeClr val="lt1"/>
+          </a:fontRef>
+        </p:style>
+        <p:txBody>
+          <a:bodyPr rtlCol="0" anchor="ctr"/>
+          <a:lstStyle/>
+          <a:p>
+            <a:pPr algn="ctr"/>
+          </a:p>
+        </p:txBody>
+      </p:sp>
+      <p:sp>
+        <p:nvSpPr>
+          <p:cNvPr id="43" name="TextBox 42"/>
+          <p:cNvSpPr txBox="1"/>
+          <p:nvPr/>
+        </p:nvSpPr>
+        <p:spPr>
+          <a:xfrm>
+            <a:off x="6208776" y="1202436"/>
+            <a:ext cx="274320" cy="329184"/>
+          </a:xfrm>
+          <a:prstGeom prst="rect">
+            <a:avLst/>
+          </a:prstGeom>
+          <a:noFill/>
+        </p:spPr>
+        <p:txBody>
+          <a:bodyPr wrap="square">
+            <a:spAutoFit/>
+          </a:bodyPr>
+          <a:lstStyle/>
+          <a:p>
+            <a:pPr algn="ctr"/>
+            <a:r>
+              <a:rPr sz="1400" b="1" i="0">
+                <a:solidFill>
+                  <a:srgbClr val="FFFFFF"/>
+                </a:solidFill>
+                <a:latin typeface="Calibri"/>
+              </a:rPr>
+              <a:t>6</a:t>
+            </a:r>
+          </a:p>
+        </p:txBody>
+      </p:sp>
+      <p:sp>
+        <p:nvSpPr>
+          <p:cNvPr id="44" name="Rectangle 43"/>
+          <p:cNvSpPr/>
+          <p:nvPr/>
+        </p:nvSpPr>
+        <p:spPr>
+          <a:xfrm>
+            <a:off x="6611112" y="768096"/>
+            <a:ext cx="1005840" cy="228600"/>
+          </a:xfrm>
+          <a:prstGeom prst="rect">
+            <a:avLst/>
+          </a:prstGeom>
+          <a:solidFill>
+            <a:srgbClr val="006BC5"/>
+          </a:solidFill>
+          <a:ln>
+            <a:noFill/>
+          </a:ln>
+        </p:spPr>
+        <p:style>
+          <a:lnRef idx="1">
+            <a:schemeClr val="accent1"/>
+          </a:lnRef>
+          <a:fillRef idx="3">
+            <a:schemeClr val="accent1"/>
+          </a:fillRef>
+          <a:effectRef idx="2">
+            <a:schemeClr val="accent1"/>
+          </a:effectRef>
+          <a:fontRef idx="minor">
+            <a:schemeClr val="lt1"/>
+          </a:fontRef>
+        </p:style>
+        <p:txBody>
+          <a:bodyPr rtlCol="0" anchor="ctr"/>
+          <a:lstStyle/>
+          <a:p>
+            <a:pPr algn="ctr"/>
+          </a:p>
+        </p:txBody>
+      </p:sp>
+      <p:sp>
+        <p:nvSpPr>
+          <p:cNvPr id="45" name="TextBox 44"/>
+          <p:cNvSpPr txBox="1"/>
+          <p:nvPr/>
+        </p:nvSpPr>
+        <p:spPr>
+          <a:xfrm>
+            <a:off x="6656832" y="777240"/>
+            <a:ext cx="914400" cy="201168"/>
+          </a:xfrm>
+          <a:prstGeom prst="rect">
+            <a:avLst/>
+          </a:prstGeom>
+          <a:noFill/>
+        </p:spPr>
+        <p:txBody>
+          <a:bodyPr wrap="square">
+            <a:spAutoFit/>
+          </a:bodyPr>
+          <a:lstStyle/>
+          <a:p>
+            <a:pPr algn="ctr"/>
+            <a:r>
+              <a:rPr sz="800" b="1" i="0">
+                <a:solidFill>
+                  <a:srgbClr val="FFFFFF"/>
+                </a:solidFill>
+                <a:latin typeface="Calibri"/>
+              </a:rPr>
+              <a:t>PM Meetings</a:t>
+            </a:r>
+          </a:p>
+        </p:txBody>
+      </p:sp>
+      <p:sp>
+        <p:nvSpPr>
+          <p:cNvPr id="46" name="TextBox 45"/>
+          <p:cNvSpPr txBox="1"/>
+          <p:nvPr/>
+        </p:nvSpPr>
+        <p:spPr>
+          <a:xfrm>
+            <a:off x="6611112" y="1014983"/>
+            <a:ext cx="5074920" cy="274320"/>
+          </a:xfrm>
+          <a:prstGeom prst="rect">
+            <a:avLst/>
+          </a:prstGeom>
+          <a:noFill/>
+        </p:spPr>
+        <p:txBody>
+          <a:bodyPr wrap="square">
+            <a:spAutoFit/>
+          </a:bodyPr>
+          <a:lstStyle/>
+          <a:p>
+            <a:pPr algn="l"/>
+            <a:r>
+              <a:rPr sz="1050" b="1" i="0">
+                <a:solidFill>
+                  <a:srgbClr val="FFFFFF"/>
+                </a:solidFill>
+                <a:latin typeface="Calibri"/>
+              </a:rPr>
+              <a:t>1:1s with PMs — Scope Gap-Fill &amp; Get Sign-off on Drafts</a:t>
+            </a:r>
+          </a:p>
+        </p:txBody>
+      </p:sp>
+      <p:sp>
+        <p:nvSpPr>
+          <p:cNvPr id="47" name="TextBox 46"/>
+          <p:cNvSpPr txBox="1"/>
+          <p:nvPr/>
+        </p:nvSpPr>
+        <p:spPr>
+          <a:xfrm>
+            <a:off x="6611112" y="1289304"/>
+            <a:ext cx="5074920" cy="640080"/>
+          </a:xfrm>
+          <a:prstGeom prst="rect">
+            <a:avLst/>
+          </a:prstGeom>
+          <a:noFill/>
+        </p:spPr>
+        <p:txBody>
+          <a:bodyPr wrap="square">
+            <a:spAutoFit/>
+          </a:bodyPr>
+          <a:lstStyle/>
+          <a:p>
+            <a:pPr algn="l"/>
+            <a:r>
+              <a:rPr sz="900" b="0" i="0">
+                <a:solidFill>
+                  <a:srgbClr val="AABBCC"/>
+                </a:solidFill>
+                <a:latin typeface="Calibri"/>
+              </a:rPr>
+              <a:t>Meet individually with PMs to confirm the 4 PM-required articles, review organizational decisions, and get formal sign-off on article scope before writing.</a:t>
+            </a:r>
+          </a:p>
+        </p:txBody>
+      </p:sp>
+      <p:sp>
+        <p:nvSpPr>
+          <p:cNvPr id="48" name="Rectangle 47"/>
+          <p:cNvSpPr/>
+          <p:nvPr/>
+        </p:nvSpPr>
+        <p:spPr>
+          <a:xfrm>
+            <a:off x="6153912" y="2103120"/>
+            <a:ext cx="5623560" cy="1362456"/>
+          </a:xfrm>
+          <a:prstGeom prst="rect">
+            <a:avLst/>
+          </a:prstGeom>
+          <a:solidFill>
+            <a:srgbClr val="0A1A3A"/>
+          </a:solidFill>
+          <a:ln>
+            <a:noFill/>
+          </a:ln>
+        </p:spPr>
+        <p:style>
+          <a:lnRef idx="1">
+            <a:schemeClr val="accent1"/>
+          </a:lnRef>
+          <a:fillRef idx="3">
+            <a:schemeClr val="accent1"/>
+          </a:fillRef>
+          <a:effectRef idx="2">
+            <a:schemeClr val="accent1"/>
+          </a:effectRef>
+          <a:fontRef idx="minor">
+            <a:schemeClr val="lt1"/>
+          </a:fontRef>
+        </p:style>
+        <p:txBody>
+          <a:bodyPr rtlCol="0" anchor="ctr"/>
+          <a:lstStyle/>
+          <a:p>
+            <a:pPr algn="ctr"/>
+          </a:p>
+        </p:txBody>
+      </p:sp>
+      <p:sp>
+        <p:nvSpPr>
+          <p:cNvPr id="49" name="Rectangle 48"/>
+          <p:cNvSpPr/>
+          <p:nvPr/>
+        </p:nvSpPr>
+        <p:spPr>
+          <a:xfrm>
+            <a:off x="6153912" y="2103120"/>
+            <a:ext cx="384048" cy="1362456"/>
+          </a:xfrm>
+          <a:prstGeom prst="rect">
+            <a:avLst/>
+          </a:prstGeom>
+          <a:solidFill>
+            <a:srgbClr val="446688"/>
+          </a:solidFill>
+          <a:ln>
+            <a:noFill/>
+          </a:ln>
+        </p:spPr>
+        <p:style>
+          <a:lnRef idx="1">
+            <a:schemeClr val="accent1"/>
+          </a:lnRef>
+          <a:fillRef idx="3">
+            <a:schemeClr val="accent1"/>
+          </a:fillRef>
+          <a:effectRef idx="2">
+            <a:schemeClr val="accent1"/>
+          </a:effectRef>
+          <a:fontRef idx="minor">
+            <a:schemeClr val="lt1"/>
+          </a:fontRef>
+        </p:style>
+        <p:txBody>
+          <a:bodyPr rtlCol="0" anchor="ctr"/>
+          <a:lstStyle/>
+          <a:p>
+            <a:pPr algn="ctr"/>
+          </a:p>
+        </p:txBody>
+      </p:sp>
+      <p:sp>
+        <p:nvSpPr>
+          <p:cNvPr id="50" name="TextBox 49"/>
+          <p:cNvSpPr txBox="1"/>
+          <p:nvPr/>
+        </p:nvSpPr>
+        <p:spPr>
+          <a:xfrm>
+            <a:off x="6208776" y="2619756"/>
+            <a:ext cx="274320" cy="329184"/>
+          </a:xfrm>
+          <a:prstGeom prst="rect">
+            <a:avLst/>
+          </a:prstGeom>
+          <a:noFill/>
+        </p:spPr>
+        <p:txBody>
+          <a:bodyPr wrap="square">
+            <a:spAutoFit/>
+          </a:bodyPr>
+          <a:lstStyle/>
+          <a:p>
+            <a:pPr algn="ctr"/>
+            <a:r>
+              <a:rPr sz="1400" b="1" i="0">
+                <a:solidFill>
+                  <a:srgbClr val="FFFFFF"/>
+                </a:solidFill>
+                <a:latin typeface="Calibri"/>
+              </a:rPr>
+              <a:t>7</a:t>
+            </a:r>
+          </a:p>
+        </p:txBody>
+      </p:sp>
+      <p:sp>
+        <p:nvSpPr>
+          <p:cNvPr id="51" name="Rectangle 50"/>
+          <p:cNvSpPr/>
+          <p:nvPr/>
+        </p:nvSpPr>
+        <p:spPr>
+          <a:xfrm>
+            <a:off x="6611112" y="2185415"/>
+            <a:ext cx="1005840" cy="228600"/>
+          </a:xfrm>
+          <a:prstGeom prst="rect">
+            <a:avLst/>
+          </a:prstGeom>
+          <a:solidFill>
+            <a:srgbClr val="446688"/>
+          </a:solidFill>
+          <a:ln>
+            <a:noFill/>
+          </a:ln>
+        </p:spPr>
+        <p:style>
+          <a:lnRef idx="1">
+            <a:schemeClr val="accent1"/>
+          </a:lnRef>
+          <a:fillRef idx="3">
+            <a:schemeClr val="accent1"/>
+          </a:fillRef>
+          <a:effectRef idx="2">
+            <a:schemeClr val="accent1"/>
+          </a:effectRef>
+          <a:fontRef idx="minor">
+            <a:schemeClr val="lt1"/>
+          </a:fontRef>
+        </p:style>
+        <p:txBody>
+          <a:bodyPr rtlCol="0" anchor="ctr"/>
+          <a:lstStyle/>
+          <a:p>
+            <a:pPr algn="ctr"/>
+          </a:p>
+        </p:txBody>
+      </p:sp>
+      <p:sp>
+        <p:nvSpPr>
+          <p:cNvPr id="52" name="TextBox 51"/>
+          <p:cNvSpPr txBox="1"/>
+          <p:nvPr/>
+        </p:nvSpPr>
+        <p:spPr>
+          <a:xfrm>
+            <a:off x="6656832" y="2194560"/>
+            <a:ext cx="914400" cy="201168"/>
+          </a:xfrm>
+          <a:prstGeom prst="rect">
+            <a:avLst/>
+          </a:prstGeom>
+          <a:noFill/>
+        </p:spPr>
+        <p:txBody>
+          <a:bodyPr wrap="square">
+            <a:spAutoFit/>
+          </a:bodyPr>
+          <a:lstStyle/>
+          <a:p>
+            <a:pPr algn="ctr"/>
+            <a:r>
+              <a:rPr sz="800" b="1" i="0">
+                <a:solidFill>
+                  <a:srgbClr val="FFFFFF"/>
+                </a:solidFill>
+                <a:latin typeface="Calibri"/>
+              </a:rPr>
+              <a:t>Support Input</a:t>
+            </a:r>
+          </a:p>
+        </p:txBody>
+      </p:sp>
+      <p:sp>
+        <p:nvSpPr>
+          <p:cNvPr id="53" name="TextBox 52"/>
+          <p:cNvSpPr txBox="1"/>
+          <p:nvPr/>
+        </p:nvSpPr>
+        <p:spPr>
+          <a:xfrm>
+            <a:off x="6611112" y="2432303"/>
+            <a:ext cx="5074920" cy="274320"/>
+          </a:xfrm>
+          <a:prstGeom prst="rect">
+            <a:avLst/>
+          </a:prstGeom>
+          <a:noFill/>
+        </p:spPr>
+        <p:txBody>
+          <a:bodyPr wrap="square">
+            <a:spAutoFit/>
+          </a:bodyPr>
+          <a:lstStyle/>
+          <a:p>
+            <a:pPr algn="l"/>
+            <a:r>
+              <a:rPr sz="1050" b="1" i="0">
+                <a:solidFill>
+                  <a:srgbClr val="FFFFFF"/>
+                </a:solidFill>
+                <a:latin typeface="Calibri"/>
+              </a:rPr>
+              <a:t>Integrate Support Team's Gap Analysis — Diff &amp; Reconcile</a:t>
+            </a:r>
+          </a:p>
+        </p:txBody>
+      </p:sp>
+      <p:sp>
+        <p:nvSpPr>
+          <p:cNvPr id="54" name="TextBox 53"/>
+          <p:cNvSpPr txBox="1"/>
+          <p:nvPr/>
+        </p:nvSpPr>
+        <p:spPr>
+          <a:xfrm>
+            <a:off x="6611112" y="2706624"/>
+            <a:ext cx="5074920" cy="640080"/>
+          </a:xfrm>
+          <a:prstGeom prst="rect">
+            <a:avLst/>
+          </a:prstGeom>
+          <a:noFill/>
+        </p:spPr>
+        <p:txBody>
+          <a:bodyPr wrap="square">
+            <a:spAutoFit/>
+          </a:bodyPr>
+          <a:lstStyle/>
+          <a:p>
+            <a:pPr algn="l"/>
+            <a:r>
+              <a:rPr sz="900" b="0" i="0">
+                <a:solidFill>
+                  <a:srgbClr val="AABBCC"/>
+                </a:solidFill>
+                <a:latin typeface="Calibri"/>
+              </a:rPr>
+              <a:t>Compare Support's gap-fill analysis against the restructure gap list; identify any delta content needs and fold them into the Phase 3a article backlog.</a:t>
+            </a:r>
+          </a:p>
+        </p:txBody>
+      </p:sp>
+      <p:sp>
+        <p:nvSpPr>
+          <p:cNvPr id="55" name="Rectangle 54"/>
+          <p:cNvSpPr/>
+          <p:nvPr/>
+        </p:nvSpPr>
+        <p:spPr>
+          <a:xfrm>
+            <a:off x="6153912" y="3520439"/>
+            <a:ext cx="5623560" cy="1362456"/>
+          </a:xfrm>
+          <a:prstGeom prst="rect">
+            <a:avLst/>
+          </a:prstGeom>
+          <a:solidFill>
+            <a:srgbClr val="0A1A3A"/>
+          </a:solidFill>
+          <a:ln>
+            <a:noFill/>
+          </a:ln>
+        </p:spPr>
+        <p:style>
+          <a:lnRef idx="1">
+            <a:schemeClr val="accent1"/>
+          </a:lnRef>
+          <a:fillRef idx="3">
+            <a:schemeClr val="accent1"/>
+          </a:fillRef>
+          <a:effectRef idx="2">
+            <a:schemeClr val="accent1"/>
+          </a:effectRef>
+          <a:fontRef idx="minor">
+            <a:schemeClr val="lt1"/>
+          </a:fontRef>
+        </p:style>
+        <p:txBody>
+          <a:bodyPr rtlCol="0" anchor="ctr"/>
+          <a:lstStyle/>
+          <a:p>
+            <a:pPr algn="ctr"/>
+          </a:p>
+        </p:txBody>
+      </p:sp>
+      <p:sp>
+        <p:nvSpPr>
+          <p:cNvPr id="56" name="Rectangle 55"/>
+          <p:cNvSpPr/>
+          <p:nvPr/>
+        </p:nvSpPr>
+        <p:spPr>
+          <a:xfrm>
+            <a:off x="6153912" y="3520439"/>
+            <a:ext cx="384048" cy="1362456"/>
+          </a:xfrm>
+          <a:prstGeom prst="rect">
+            <a:avLst/>
+          </a:prstGeom>
+          <a:solidFill>
+            <a:srgbClr val="00AB6C"/>
+          </a:solidFill>
+          <a:ln>
+            <a:noFill/>
+          </a:ln>
+        </p:spPr>
+        <p:style>
+          <a:lnRef idx="1">
+            <a:schemeClr val="accent1"/>
+          </a:lnRef>
+          <a:fillRef idx="3">
+            <a:schemeClr val="accent1"/>
+          </a:fillRef>
+          <a:effectRef idx="2">
+            <a:schemeClr val="accent1"/>
+          </a:effectRef>
+          <a:fontRef idx="minor">
+            <a:schemeClr val="lt1"/>
+          </a:fontRef>
+        </p:style>
+        <p:txBody>
+          <a:bodyPr rtlCol="0" anchor="ctr"/>
+          <a:lstStyle/>
+          <a:p>
+            <a:pPr algn="ctr"/>
+          </a:p>
+        </p:txBody>
+      </p:sp>
+      <p:sp>
+        <p:nvSpPr>
+          <p:cNvPr id="57" name="TextBox 56"/>
+          <p:cNvSpPr txBox="1"/>
+          <p:nvPr/>
+        </p:nvSpPr>
+        <p:spPr>
+          <a:xfrm>
+            <a:off x="6208776" y="4037076"/>
+            <a:ext cx="274320" cy="329184"/>
+          </a:xfrm>
+          <a:prstGeom prst="rect">
+            <a:avLst/>
+          </a:prstGeom>
+          <a:noFill/>
+        </p:spPr>
+        <p:txBody>
+          <a:bodyPr wrap="square">
+            <a:spAutoFit/>
+          </a:bodyPr>
+          <a:lstStyle/>
+          <a:p>
+            <a:pPr algn="ctr"/>
+            <a:r>
+              <a:rPr sz="1400" b="1" i="0">
+                <a:solidFill>
+                  <a:srgbClr val="FFFFFF"/>
+                </a:solidFill>
+                <a:latin typeface="Calibri"/>
+              </a:rPr>
+              <a:t>8</a:t>
+            </a:r>
+          </a:p>
+        </p:txBody>
+      </p:sp>
+      <p:sp>
+        <p:nvSpPr>
+          <p:cNvPr id="58" name="Rectangle 57"/>
+          <p:cNvSpPr/>
+          <p:nvPr/>
+        </p:nvSpPr>
+        <p:spPr>
+          <a:xfrm>
+            <a:off x="6611112" y="3602735"/>
+            <a:ext cx="1005840" cy="228600"/>
+          </a:xfrm>
+          <a:prstGeom prst="rect">
+            <a:avLst/>
+          </a:prstGeom>
+          <a:solidFill>
+            <a:srgbClr val="00AB6C"/>
+          </a:solidFill>
+          <a:ln>
+            <a:noFill/>
+          </a:ln>
+        </p:spPr>
+        <p:style>
+          <a:lnRef idx="1">
+            <a:schemeClr val="accent1"/>
+          </a:lnRef>
+          <a:fillRef idx="3">
+            <a:schemeClr val="accent1"/>
+          </a:fillRef>
+          <a:effectRef idx="2">
+            <a:schemeClr val="accent1"/>
+          </a:effectRef>
+          <a:fontRef idx="minor">
+            <a:schemeClr val="lt1"/>
+          </a:fontRef>
+        </p:style>
+        <p:txBody>
+          <a:bodyPr rtlCol="0" anchor="ctr"/>
+          <a:lstStyle/>
+          <a:p>
+            <a:pPr algn="ctr"/>
+          </a:p>
+        </p:txBody>
+      </p:sp>
+      <p:sp>
+        <p:nvSpPr>
+          <p:cNvPr id="59" name="TextBox 58"/>
+          <p:cNvSpPr txBox="1"/>
+          <p:nvPr/>
+        </p:nvSpPr>
+        <p:spPr>
+          <a:xfrm>
+            <a:off x="6656832" y="3611879"/>
+            <a:ext cx="914400" cy="201168"/>
+          </a:xfrm>
+          <a:prstGeom prst="rect">
+            <a:avLst/>
+          </a:prstGeom>
+          <a:noFill/>
+        </p:spPr>
+        <p:txBody>
+          <a:bodyPr wrap="square">
+            <a:spAutoFit/>
+          </a:bodyPr>
+          <a:lstStyle/>
+          <a:p>
+            <a:pPr algn="ctr"/>
+            <a:r>
+              <a:rPr sz="800" b="1" i="0">
+                <a:solidFill>
+                  <a:srgbClr val="FFFFFF"/>
+                </a:solidFill>
+                <a:latin typeface="Calibri"/>
+              </a:rPr>
+              <a:t>Phase 3a</a:t>
+            </a:r>
+          </a:p>
+        </p:txBody>
+      </p:sp>
+      <p:sp>
+        <p:nvSpPr>
+          <p:cNvPr id="60" name="TextBox 59"/>
+          <p:cNvSpPr txBox="1"/>
+          <p:nvPr/>
+        </p:nvSpPr>
+        <p:spPr>
+          <a:xfrm>
+            <a:off x="6611112" y="3849624"/>
+            <a:ext cx="5074920" cy="274320"/>
+          </a:xfrm>
+          <a:prstGeom prst="rect">
+            <a:avLst/>
+          </a:prstGeom>
+          <a:noFill/>
+        </p:spPr>
+        <p:txBody>
+          <a:bodyPr wrap="square">
+            <a:spAutoFit/>
+          </a:bodyPr>
+          <a:lstStyle/>
+          <a:p>
+            <a:pPr algn="l"/>
+            <a:r>
+              <a:rPr sz="1050" b="1" i="0">
+                <a:solidFill>
+                  <a:srgbClr val="FFFFFF"/>
+                </a:solidFill>
+                <a:latin typeface="Calibri"/>
+              </a:rPr>
+              <a:t>Write All Gap-Fill Articles</a:t>
+            </a:r>
+          </a:p>
+        </p:txBody>
+      </p:sp>
+      <p:sp>
+        <p:nvSpPr>
+          <p:cNvPr id="61" name="TextBox 60"/>
+          <p:cNvSpPr txBox="1"/>
+          <p:nvPr/>
+        </p:nvSpPr>
+        <p:spPr>
+          <a:xfrm>
+            <a:off x="6611112" y="4123944"/>
+            <a:ext cx="5074920" cy="640080"/>
+          </a:xfrm>
+          <a:prstGeom prst="rect">
+            <a:avLst/>
+          </a:prstGeom>
+          <a:noFill/>
+        </p:spPr>
+        <p:txBody>
+          <a:bodyPr wrap="square">
+            <a:spAutoFit/>
+          </a:bodyPr>
+          <a:lstStyle/>
+          <a:p>
+            <a:pPr algn="l"/>
+            <a:r>
+              <a:rPr sz="900" b="0" i="0">
+                <a:solidFill>
+                  <a:srgbClr val="AABBCC"/>
+                </a:solidFill>
+                <a:latin typeface="Calibri"/>
+              </a:rPr>
+              <a:t>Execute Phase 3a content creation in priority order using new-kb-article and new-overview-article skills; add each to nav immediately after creation.</a:t>
+            </a:r>
+          </a:p>
+        </p:txBody>
+      </p:sp>
+      <p:sp>
+        <p:nvSpPr>
+          <p:cNvPr id="62" name="Rectangle 61"/>
+          <p:cNvSpPr/>
+          <p:nvPr/>
+        </p:nvSpPr>
+        <p:spPr>
+          <a:xfrm>
+            <a:off x="6153912" y="4937759"/>
+            <a:ext cx="5623560" cy="1362456"/>
+          </a:xfrm>
+          <a:prstGeom prst="rect">
+            <a:avLst/>
+          </a:prstGeom>
+          <a:solidFill>
+            <a:srgbClr val="0A1A3A"/>
+          </a:solidFill>
+          <a:ln>
+            <a:noFill/>
+          </a:ln>
+        </p:spPr>
+        <p:style>
+          <a:lnRef idx="1">
+            <a:schemeClr val="accent1"/>
+          </a:lnRef>
+          <a:fillRef idx="3">
+            <a:schemeClr val="accent1"/>
+          </a:fillRef>
+          <a:effectRef idx="2">
+            <a:schemeClr val="accent1"/>
+          </a:effectRef>
+          <a:fontRef idx="minor">
+            <a:schemeClr val="lt1"/>
+          </a:fontRef>
+        </p:style>
+        <p:txBody>
+          <a:bodyPr rtlCol="0" anchor="ctr"/>
+          <a:lstStyle/>
+          <a:p>
+            <a:pPr algn="ctr"/>
+          </a:p>
+        </p:txBody>
+      </p:sp>
+      <p:sp>
+        <p:nvSpPr>
+          <p:cNvPr id="63" name="Rectangle 62"/>
+          <p:cNvSpPr/>
+          <p:nvPr/>
+        </p:nvSpPr>
+        <p:spPr>
+          <a:xfrm>
+            <a:off x="6153912" y="4937759"/>
+            <a:ext cx="384048" cy="1362456"/>
+          </a:xfrm>
+          <a:prstGeom prst="rect">
+            <a:avLst/>
+          </a:prstGeom>
+          <a:solidFill>
+            <a:srgbClr val="8C9BAA"/>
+          </a:solidFill>
+          <a:ln>
+            <a:noFill/>
+          </a:ln>
+        </p:spPr>
+        <p:style>
+          <a:lnRef idx="1">
+            <a:schemeClr val="accent1"/>
+          </a:lnRef>
+          <a:fillRef idx="3">
+            <a:schemeClr val="accent1"/>
+          </a:fillRef>
+          <a:effectRef idx="2">
+            <a:schemeClr val="accent1"/>
+          </a:effectRef>
+          <a:fontRef idx="minor">
+            <a:schemeClr val="lt1"/>
+          </a:fontRef>
+        </p:style>
+        <p:txBody>
+          <a:bodyPr rtlCol="0" anchor="ctr"/>
+          <a:lstStyle/>
+          <a:p>
+            <a:pPr algn="ctr"/>
+          </a:p>
+        </p:txBody>
+      </p:sp>
+      <p:sp>
+        <p:nvSpPr>
+          <p:cNvPr id="64" name="TextBox 63"/>
+          <p:cNvSpPr txBox="1"/>
+          <p:nvPr/>
+        </p:nvSpPr>
+        <p:spPr>
+          <a:xfrm>
+            <a:off x="6208776" y="5454396"/>
+            <a:ext cx="274320" cy="329184"/>
+          </a:xfrm>
+          <a:prstGeom prst="rect">
+            <a:avLst/>
+          </a:prstGeom>
+          <a:noFill/>
+        </p:spPr>
+        <p:txBody>
+          <a:bodyPr wrap="square">
+            <a:spAutoFit/>
+          </a:bodyPr>
+          <a:lstStyle/>
+          <a:p>
+            <a:pPr algn="ctr"/>
+            <a:r>
+              <a:rPr sz="1400" b="1" i="0">
+                <a:solidFill>
+                  <a:srgbClr val="FFFFFF"/>
+                </a:solidFill>
+                <a:latin typeface="Calibri"/>
+              </a:rPr>
+              <a:t>9</a:t>
+            </a:r>
+          </a:p>
+        </p:txBody>
+      </p:sp>
+      <p:sp>
+        <p:nvSpPr>
+          <p:cNvPr id="65" name="Rectangle 64"/>
+          <p:cNvSpPr/>
+          <p:nvPr/>
+        </p:nvSpPr>
+        <p:spPr>
+          <a:xfrm>
+            <a:off x="6611112" y="5020055"/>
+            <a:ext cx="1005840" cy="228600"/>
+          </a:xfrm>
+          <a:prstGeom prst="rect">
+            <a:avLst/>
+          </a:prstGeom>
+          <a:solidFill>
+            <a:srgbClr val="8C9BAA"/>
+          </a:solidFill>
+          <a:ln>
+            <a:noFill/>
+          </a:ln>
+        </p:spPr>
+        <p:style>
+          <a:lnRef idx="1">
+            <a:schemeClr val="accent1"/>
+          </a:lnRef>
+          <a:fillRef idx="3">
+            <a:schemeClr val="accent1"/>
+          </a:fillRef>
+          <a:effectRef idx="2">
+            <a:schemeClr val="accent1"/>
+          </a:effectRef>
+          <a:fontRef idx="minor">
+            <a:schemeClr val="lt1"/>
+          </a:fontRef>
+        </p:style>
+        <p:txBody>
+          <a:bodyPr rtlCol="0" anchor="ctr"/>
+          <a:lstStyle/>
+          <a:p>
+            <a:pPr algn="ctr"/>
+          </a:p>
+        </p:txBody>
+      </p:sp>
+      <p:sp>
+        <p:nvSpPr>
+          <p:cNvPr id="66" name="TextBox 65"/>
+          <p:cNvSpPr txBox="1"/>
+          <p:nvPr/>
+        </p:nvSpPr>
+        <p:spPr>
+          <a:xfrm>
+            <a:off x="6656832" y="5029199"/>
+            <a:ext cx="914400" cy="201168"/>
+          </a:xfrm>
+          <a:prstGeom prst="rect">
+            <a:avLst/>
+          </a:prstGeom>
+          <a:noFill/>
+        </p:spPr>
+        <p:txBody>
+          <a:bodyPr wrap="square">
+            <a:spAutoFit/>
+          </a:bodyPr>
+          <a:lstStyle/>
+          <a:p>
+            <a:pPr algn="ctr"/>
+            <a:r>
+              <a:rPr sz="800" b="1" i="0">
+                <a:solidFill>
+                  <a:srgbClr val="FFFFFF"/>
+                </a:solidFill>
+                <a:latin typeface="Calibri"/>
+              </a:rPr>
+              <a:t>Pre-merge</a:t>
+            </a:r>
+          </a:p>
+        </p:txBody>
+      </p:sp>
+      <p:sp>
+        <p:nvSpPr>
+          <p:cNvPr id="67" name="TextBox 66"/>
+          <p:cNvSpPr txBox="1"/>
+          <p:nvPr/>
+        </p:nvSpPr>
+        <p:spPr>
+          <a:xfrm>
+            <a:off x="6611112" y="5266944"/>
+            <a:ext cx="5074920" cy="274320"/>
+          </a:xfrm>
+          <a:prstGeom prst="rect">
+            <a:avLst/>
+          </a:prstGeom>
+          <a:noFill/>
+        </p:spPr>
+        <p:txBody>
+          <a:bodyPr wrap="square">
+            <a:spAutoFit/>
+          </a:bodyPr>
+          <a:lstStyle/>
+          <a:p>
+            <a:pPr algn="l"/>
+            <a:r>
+              <a:rPr sz="1050" b="1" i="0">
+                <a:solidFill>
+                  <a:srgbClr val="FFFFFF"/>
+                </a:solidFill>
+                <a:latin typeface="Calibri"/>
+              </a:rPr>
+              <a:t>Final Review Pass — Validate, Fix, and Merge</a:t>
+            </a:r>
+          </a:p>
+        </p:txBody>
+      </p:sp>
+      <p:sp>
+        <p:nvSpPr>
+          <p:cNvPr id="68" name="TextBox 67"/>
+          <p:cNvSpPr txBox="1"/>
+          <p:nvPr/>
+        </p:nvSpPr>
+        <p:spPr>
+          <a:xfrm>
+            <a:off x="6611112" y="5541264"/>
+            <a:ext cx="5074920" cy="640080"/>
+          </a:xfrm>
+          <a:prstGeom prst="rect">
+            <a:avLst/>
+          </a:prstGeom>
+          <a:noFill/>
+        </p:spPr>
+        <p:txBody>
+          <a:bodyPr wrap="square">
+            <a:spAutoFit/>
+          </a:bodyPr>
+          <a:lstStyle/>
+          <a:p>
+            <a:pPr algn="l"/>
+            <a:r>
+              <a:rPr sz="900" b="0" i="0">
+                <a:solidFill>
+                  <a:srgbClr val="AABBCC"/>
+                </a:solidFill>
+                <a:latin typeface="Calibri"/>
+              </a:rPr>
+              <a:t>Run nav validator; resolve broken refs; do a final content and style review; merge the restructure branch to main.</a:t>
             </a:r>
           </a:p>
         </p:txBody>

</xml_diff>